<commit_message>
feat: add direct clickable live portal buttons and URLs to Slide 4 in pitch deck
</commit_message>
<xml_diff>
--- a/MicroCRM_Pitch_Deck.pptx
+++ b/MicroCRM_Pitch_Deck.pptx
@@ -5480,8 +5480,8 @@
         </p:nvSpPr>
         <p:spPr>
           <a:xfrm>
-            <a:off x="960120" y="2560320"/>
-            <a:ext cx="2999232" cy="365760"/>
+            <a:off x="960120" y="2542032"/>
+            <a:ext cx="2999232" cy="320040"/>
           </a:xfrm>
           <a:prstGeom prst="rect">
             <a:avLst/>
@@ -5516,8 +5516,8 @@
         </p:nvSpPr>
         <p:spPr>
           <a:xfrm>
-            <a:off x="960120" y="2926080"/>
-            <a:ext cx="2999232" cy="365760"/>
+            <a:off x="960120" y="2852928"/>
+            <a:ext cx="2999232" cy="320040"/>
           </a:xfrm>
           <a:prstGeom prst="rect">
             <a:avLst/>
@@ -5530,16 +5530,15 @@
           </a:bodyPr>
           <a:lstStyle/>
           <a:p>
-            <a:pPr>
-              <a:defRPr sz="950">
+            <a:r>
+              <a:rPr sz="950" b="1" u="sng">
                 <a:solidFill>
                   <a:srgbClr val="60A5FA"/>
                 </a:solidFill>
                 <a:latin typeface="Segoe UI"/>
-              </a:defRPr>
-            </a:pPr>
-            <a:r>
-              <a:t>Live Portal: app.microcrm.site/book/rashmi-r-makeup</a:t>
+                <a:hlinkClick r:id="rId2"/>
+              </a:rPr>
+              <a:t>🔗 app.microcrm.site/book/rashmi-r-makeup</a:t>
             </a:r>
           </a:p>
         </p:txBody>
@@ -5552,8 +5551,8 @@
         </p:nvSpPr>
         <p:spPr>
           <a:xfrm>
-            <a:off x="960120" y="3383280"/>
-            <a:ext cx="2999232" cy="2377440"/>
+            <a:off x="960120" y="3218688"/>
+            <a:ext cx="2999232" cy="2148840"/>
           </a:xfrm>
           <a:prstGeom prst="rect">
             <a:avLst/>
@@ -5568,9 +5567,9 @@
           <a:p>
             <a:pPr>
               <a:spcAft>
-                <a:spcPts val="800"/>
+                <a:spcPts val="600"/>
               </a:spcAft>
-              <a:defRPr sz="1100">
+              <a:defRPr sz="1050">
                 <a:solidFill>
                   <a:srgbClr val="E2E8F0"/>
                 </a:solidFill>
@@ -5584,9 +5583,9 @@
           <a:p>
             <a:pPr>
               <a:spcAft>
-                <a:spcPts val="800"/>
+                <a:spcPts val="600"/>
               </a:spcAft>
-              <a:defRPr sz="1100">
+              <a:defRPr sz="1050">
                 <a:solidFill>
                   <a:srgbClr val="E2E8F0"/>
                 </a:solidFill>
@@ -5600,9 +5599,9 @@
           <a:p>
             <a:pPr>
               <a:spcAft>
-                <a:spcPts val="800"/>
+                <a:spcPts val="600"/>
               </a:spcAft>
-              <a:defRPr sz="1100">
+              <a:defRPr sz="1050">
                 <a:solidFill>
                   <a:srgbClr val="E2E8F0"/>
                 </a:solidFill>
@@ -5618,6 +5617,61 @@
       <p:sp>
         <p:nvSpPr>
           <p:cNvPr id="11" name="Rounded Rectangle 10"/>
+          <p:cNvSpPr/>
+          <p:nvPr/>
+        </p:nvSpPr>
+        <p:spPr>
+          <a:xfrm>
+            <a:off x="960120" y="5468112"/>
+            <a:ext cx="2999232" cy="384048"/>
+          </a:xfrm>
+          <a:prstGeom prst="roundRect">
+            <a:avLst/>
+          </a:prstGeom>
+          <a:solidFill>
+            <a:srgbClr val="111827"/>
+          </a:solidFill>
+          <a:ln>
+            <a:solidFill>
+              <a:srgbClr val="F472B6"/>
+            </a:solidFill>
+          </a:ln>
+        </p:spPr>
+        <p:style>
+          <a:lnRef idx="1">
+            <a:schemeClr val="accent1"/>
+          </a:lnRef>
+          <a:fillRef idx="3">
+            <a:schemeClr val="accent1"/>
+          </a:fillRef>
+          <a:effectRef idx="2">
+            <a:schemeClr val="accent1"/>
+          </a:effectRef>
+          <a:fontRef idx="minor">
+            <a:schemeClr val="lt1"/>
+          </a:fontRef>
+        </p:style>
+        <p:txBody>
+          <a:bodyPr rtlCol="0" anchor="ctr"/>
+          <a:lstStyle/>
+          <a:p>
+            <a:pPr algn="ctr"/>
+            <a:r>
+              <a:rPr sz="1000" b="1">
+                <a:solidFill>
+                  <a:srgbClr val="F472B6"/>
+                </a:solidFill>
+                <a:latin typeface="Segoe UI"/>
+                <a:hlinkClick r:id="rId2"/>
+              </a:rPr>
+              <a:t>Open Live Client Portal ↗</a:t>
+            </a:r>
+          </a:p>
+        </p:txBody>
+      </p:sp>
+      <p:sp>
+        <p:nvSpPr>
+          <p:cNvPr id="12" name="Rounded Rectangle 11"/>
           <p:cNvSpPr/>
           <p:nvPr/>
         </p:nvSpPr>
@@ -5662,7 +5716,7 @@
       </p:sp>
       <p:sp>
         <p:nvSpPr>
-          <p:cNvPr id="12" name="TextBox 11"/>
+          <p:cNvPr id="13" name="TextBox 12"/>
           <p:cNvSpPr txBox="1"/>
           <p:nvPr/>
         </p:nvSpPr>
@@ -5698,14 +5752,14 @@
       </p:sp>
       <p:sp>
         <p:nvSpPr>
-          <p:cNvPr id="13" name="TextBox 12"/>
+          <p:cNvPr id="14" name="TextBox 13"/>
           <p:cNvSpPr txBox="1"/>
           <p:nvPr/>
         </p:nvSpPr>
         <p:spPr>
           <a:xfrm>
-            <a:off x="4690872" y="2560320"/>
-            <a:ext cx="2999232" cy="365760"/>
+            <a:off x="4690872" y="2542032"/>
+            <a:ext cx="2999232" cy="320040"/>
           </a:xfrm>
           <a:prstGeom prst="rect">
             <a:avLst/>
@@ -5734,14 +5788,14 @@
       </p:sp>
       <p:sp>
         <p:nvSpPr>
-          <p:cNvPr id="14" name="TextBox 13"/>
+          <p:cNvPr id="15" name="TextBox 14"/>
           <p:cNvSpPr txBox="1"/>
           <p:nvPr/>
         </p:nvSpPr>
         <p:spPr>
           <a:xfrm>
-            <a:off x="4690872" y="2926080"/>
-            <a:ext cx="2999232" cy="365760"/>
+            <a:off x="4690872" y="2852928"/>
+            <a:ext cx="2999232" cy="320040"/>
           </a:xfrm>
           <a:prstGeom prst="rect">
             <a:avLst/>
@@ -5754,30 +5808,29 @@
           </a:bodyPr>
           <a:lstStyle/>
           <a:p>
-            <a:pPr>
-              <a:defRPr sz="950">
+            <a:r>
+              <a:rPr sz="950" b="1" u="sng">
                 <a:solidFill>
                   <a:srgbClr val="60A5FA"/>
                 </a:solidFill>
                 <a:latin typeface="Segoe UI"/>
-              </a:defRPr>
-            </a:pPr>
-            <a:r>
-              <a:t>Live Portal: app.microcrm.site/book/shri-ranawat-infotech</a:t>
-            </a:r>
-          </a:p>
-        </p:txBody>
-      </p:sp>
-      <p:sp>
-        <p:nvSpPr>
-          <p:cNvPr id="15" name="TextBox 14"/>
+                <a:hlinkClick r:id="rId3"/>
+              </a:rPr>
+              <a:t>🔗 app.microcrm.site/book/shri-ranawat-infotech</a:t>
+            </a:r>
+          </a:p>
+        </p:txBody>
+      </p:sp>
+      <p:sp>
+        <p:nvSpPr>
+          <p:cNvPr id="16" name="TextBox 15"/>
           <p:cNvSpPr txBox="1"/>
           <p:nvPr/>
         </p:nvSpPr>
         <p:spPr>
           <a:xfrm>
-            <a:off x="4690872" y="3383280"/>
-            <a:ext cx="2999232" cy="2377440"/>
+            <a:off x="4690872" y="3218688"/>
+            <a:ext cx="2999232" cy="2148840"/>
           </a:xfrm>
           <a:prstGeom prst="rect">
             <a:avLst/>
@@ -5792,9 +5845,9 @@
           <a:p>
             <a:pPr>
               <a:spcAft>
-                <a:spcPts val="800"/>
+                <a:spcPts val="600"/>
               </a:spcAft>
-              <a:defRPr sz="1100">
+              <a:defRPr sz="1050">
                 <a:solidFill>
                   <a:srgbClr val="E2E8F0"/>
                 </a:solidFill>
@@ -5808,9 +5861,9 @@
           <a:p>
             <a:pPr>
               <a:spcAft>
-                <a:spcPts val="800"/>
+                <a:spcPts val="600"/>
               </a:spcAft>
-              <a:defRPr sz="1100">
+              <a:defRPr sz="1050">
                 <a:solidFill>
                   <a:srgbClr val="E2E8F0"/>
                 </a:solidFill>
@@ -5824,9 +5877,9 @@
           <a:p>
             <a:pPr>
               <a:spcAft>
-                <a:spcPts val="800"/>
+                <a:spcPts val="600"/>
               </a:spcAft>
-              <a:defRPr sz="1100">
+              <a:defRPr sz="1050">
                 <a:solidFill>
                   <a:srgbClr val="E2E8F0"/>
                 </a:solidFill>
@@ -5841,7 +5894,62 @@
       </p:sp>
       <p:sp>
         <p:nvSpPr>
-          <p:cNvPr id="16" name="Rounded Rectangle 15"/>
+          <p:cNvPr id="17" name="Rounded Rectangle 16"/>
+          <p:cNvSpPr/>
+          <p:nvPr/>
+        </p:nvSpPr>
+        <p:spPr>
+          <a:xfrm>
+            <a:off x="4690872" y="5468112"/>
+            <a:ext cx="2999232" cy="384048"/>
+          </a:xfrm>
+          <a:prstGeom prst="roundRect">
+            <a:avLst/>
+          </a:prstGeom>
+          <a:solidFill>
+            <a:srgbClr val="111827"/>
+          </a:solidFill>
+          <a:ln>
+            <a:solidFill>
+              <a:srgbClr val="60A5FA"/>
+            </a:solidFill>
+          </a:ln>
+        </p:spPr>
+        <p:style>
+          <a:lnRef idx="1">
+            <a:schemeClr val="accent1"/>
+          </a:lnRef>
+          <a:fillRef idx="3">
+            <a:schemeClr val="accent1"/>
+          </a:fillRef>
+          <a:effectRef idx="2">
+            <a:schemeClr val="accent1"/>
+          </a:effectRef>
+          <a:fontRef idx="minor">
+            <a:schemeClr val="lt1"/>
+          </a:fontRef>
+        </p:style>
+        <p:txBody>
+          <a:bodyPr rtlCol="0" anchor="ctr"/>
+          <a:lstStyle/>
+          <a:p>
+            <a:pPr algn="ctr"/>
+            <a:r>
+              <a:rPr sz="1000" b="1">
+                <a:solidFill>
+                  <a:srgbClr val="60A5FA"/>
+                </a:solidFill>
+                <a:latin typeface="Segoe UI"/>
+                <a:hlinkClick r:id="rId3"/>
+              </a:rPr>
+              <a:t>Open Live Client Portal ↗</a:t>
+            </a:r>
+          </a:p>
+        </p:txBody>
+      </p:sp>
+      <p:sp>
+        <p:nvSpPr>
+          <p:cNvPr id="18" name="Rounded Rectangle 17"/>
           <p:cNvSpPr/>
           <p:nvPr/>
         </p:nvSpPr>
@@ -5886,7 +5994,7 @@
       </p:sp>
       <p:sp>
         <p:nvSpPr>
-          <p:cNvPr id="17" name="TextBox 16"/>
+          <p:cNvPr id="19" name="TextBox 18"/>
           <p:cNvSpPr txBox="1"/>
           <p:nvPr/>
         </p:nvSpPr>
@@ -5922,14 +6030,14 @@
       </p:sp>
       <p:sp>
         <p:nvSpPr>
-          <p:cNvPr id="18" name="TextBox 17"/>
+          <p:cNvPr id="20" name="TextBox 19"/>
           <p:cNvSpPr txBox="1"/>
           <p:nvPr/>
         </p:nvSpPr>
         <p:spPr>
           <a:xfrm>
-            <a:off x="8421624" y="2560320"/>
-            <a:ext cx="2999232" cy="365760"/>
+            <a:off x="8421624" y="2542032"/>
+            <a:ext cx="2999232" cy="320040"/>
           </a:xfrm>
           <a:prstGeom prst="rect">
             <a:avLst/>
@@ -5958,14 +6066,14 @@
       </p:sp>
       <p:sp>
         <p:nvSpPr>
-          <p:cNvPr id="19" name="TextBox 18"/>
+          <p:cNvPr id="21" name="TextBox 20"/>
           <p:cNvSpPr txBox="1"/>
           <p:nvPr/>
         </p:nvSpPr>
         <p:spPr>
           <a:xfrm>
-            <a:off x="8421624" y="2926080"/>
-            <a:ext cx="2999232" cy="365760"/>
+            <a:off x="8421624" y="2852928"/>
+            <a:ext cx="2999232" cy="320040"/>
           </a:xfrm>
           <a:prstGeom prst="rect">
             <a:avLst/>
@@ -5978,30 +6086,29 @@
           </a:bodyPr>
           <a:lstStyle/>
           <a:p>
-            <a:pPr>
-              <a:defRPr sz="950">
+            <a:r>
+              <a:rPr sz="950" b="1" u="sng">
                 <a:solidFill>
                   <a:srgbClr val="60A5FA"/>
                 </a:solidFill>
                 <a:latin typeface="Segoe UI"/>
-              </a:defRPr>
-            </a:pPr>
-            <a:r>
-              <a:t>Live Portal: app.microcrm.site/book/bbc</a:t>
-            </a:r>
-          </a:p>
-        </p:txBody>
-      </p:sp>
-      <p:sp>
-        <p:nvSpPr>
-          <p:cNvPr id="20" name="TextBox 19"/>
+                <a:hlinkClick r:id="rId4"/>
+              </a:rPr>
+              <a:t>🔗 app.microcrm.site/book/bbc</a:t>
+            </a:r>
+          </a:p>
+        </p:txBody>
+      </p:sp>
+      <p:sp>
+        <p:nvSpPr>
+          <p:cNvPr id="22" name="TextBox 21"/>
           <p:cNvSpPr txBox="1"/>
           <p:nvPr/>
         </p:nvSpPr>
         <p:spPr>
           <a:xfrm>
-            <a:off x="8421624" y="3383280"/>
-            <a:ext cx="2999232" cy="2377440"/>
+            <a:off x="8421624" y="3218688"/>
+            <a:ext cx="2999232" cy="2148840"/>
           </a:xfrm>
           <a:prstGeom prst="rect">
             <a:avLst/>
@@ -6016,9 +6123,9 @@
           <a:p>
             <a:pPr>
               <a:spcAft>
-                <a:spcPts val="800"/>
+                <a:spcPts val="600"/>
               </a:spcAft>
-              <a:defRPr sz="1100">
+              <a:defRPr sz="1050">
                 <a:solidFill>
                   <a:srgbClr val="E2E8F0"/>
                 </a:solidFill>
@@ -6032,9 +6139,9 @@
           <a:p>
             <a:pPr>
               <a:spcAft>
-                <a:spcPts val="800"/>
+                <a:spcPts val="600"/>
               </a:spcAft>
-              <a:defRPr sz="1100">
+              <a:defRPr sz="1050">
                 <a:solidFill>
                   <a:srgbClr val="E2E8F0"/>
                 </a:solidFill>
@@ -6048,9 +6155,9 @@
           <a:p>
             <a:pPr>
               <a:spcAft>
-                <a:spcPts val="800"/>
+                <a:spcPts val="600"/>
               </a:spcAft>
-              <a:defRPr sz="1100">
+              <a:defRPr sz="1050">
                 <a:solidFill>
                   <a:srgbClr val="E2E8F0"/>
                 </a:solidFill>
@@ -6059,6 +6166,61 @@
             </a:pPr>
             <a:r>
               <a:t>Result: Inbound ad leads get automated brochure in 2 minutes; 392% higher site visit conversion.</a:t>
+            </a:r>
+          </a:p>
+        </p:txBody>
+      </p:sp>
+      <p:sp>
+        <p:nvSpPr>
+          <p:cNvPr id="23" name="Rounded Rectangle 22"/>
+          <p:cNvSpPr/>
+          <p:nvPr/>
+        </p:nvSpPr>
+        <p:spPr>
+          <a:xfrm>
+            <a:off x="8421624" y="5468112"/>
+            <a:ext cx="2999232" cy="384048"/>
+          </a:xfrm>
+          <a:prstGeom prst="roundRect">
+            <a:avLst/>
+          </a:prstGeom>
+          <a:solidFill>
+            <a:srgbClr val="111827"/>
+          </a:solidFill>
+          <a:ln>
+            <a:solidFill>
+              <a:srgbClr val="10B981"/>
+            </a:solidFill>
+          </a:ln>
+        </p:spPr>
+        <p:style>
+          <a:lnRef idx="1">
+            <a:schemeClr val="accent1"/>
+          </a:lnRef>
+          <a:fillRef idx="3">
+            <a:schemeClr val="accent1"/>
+          </a:fillRef>
+          <a:effectRef idx="2">
+            <a:schemeClr val="accent1"/>
+          </a:effectRef>
+          <a:fontRef idx="minor">
+            <a:schemeClr val="lt1"/>
+          </a:fontRef>
+        </p:style>
+        <p:txBody>
+          <a:bodyPr rtlCol="0" anchor="ctr"/>
+          <a:lstStyle/>
+          <a:p>
+            <a:pPr algn="ctr"/>
+            <a:r>
+              <a:rPr sz="1000" b="1">
+                <a:solidFill>
+                  <a:srgbClr val="10B981"/>
+                </a:solidFill>
+                <a:latin typeface="Segoe UI"/>
+                <a:hlinkClick r:id="rId4"/>
+              </a:rPr>
+              <a:t>Open Live Client Portal ↗</a:t>
             </a:r>
           </a:p>
         </p:txBody>

</xml_diff>